<commit_message>
Update 릴레이 초상화 assets and add ZIP slides
Co-Authored-By: Claude Opus 4.6 (1M context) <noreply@anthropic.com>
</commit_message>
<xml_diff>
--- a/public/downloads/games/relay-portrait/rules.pptx
+++ b/public/downloads/games/relay-portrait/rules.pptx
@@ -25,16 +25,12 @@
   <p:notesSz cx="6858000" cy="9144000"/>
   <p:embeddedFontLst>
     <p:embeddedFont>
-      <p:font typeface="Jua" charset="1" panose="00000000000000000000"/>
+      <p:font typeface="무궁화 고딕" charset="1" panose="02020603020101020101"/>
       <p:regular r:id="rId21"/>
     </p:embeddedFont>
     <p:embeddedFont>
-      <p:font typeface="TDTD갬성명조" charset="1" panose="02000503000000000000"/>
+      <p:font typeface="무궁화 고딕 Bold" charset="1" panose="02020603020101020101"/>
       <p:regular r:id="rId22"/>
-    </p:embeddedFont>
-    <p:embeddedFont>
-      <p:font typeface="TDTD가온" charset="1" panose="02000503000000000000"/>
-      <p:regular r:id="rId23"/>
     </p:embeddedFont>
   </p:embeddedFontLst>
   <p:defaultTextStyle>
@@ -3152,8 +3148,8 @@
         </p:nvSpPr>
         <p:spPr>
           <a:xfrm rot="0">
-            <a:off x="1028700" y="3892867"/>
-            <a:ext cx="15555091" cy="2200275"/>
+            <a:off x="1028700" y="4178617"/>
+            <a:ext cx="15555091" cy="1914525"/>
           </a:xfrm>
           <a:prstGeom prst="rect">
             <a:avLst/>
@@ -3175,10 +3171,10 @@
                 <a:solidFill>
                   <a:srgbClr val="FFFAEF"/>
                 </a:solidFill>
-                <a:latin typeface="Jua"/>
-                <a:ea typeface="Jua"/>
-                <a:cs typeface="Jua"/>
-                <a:sym typeface="Jua"/>
+                <a:latin typeface="무궁화 고딕"/>
+                <a:ea typeface="무궁화 고딕"/>
+                <a:cs typeface="무궁화 고딕"/>
+                <a:sym typeface="무궁화 고딕"/>
               </a:rPr>
               <a:t>릴레이 초상화</a:t>
             </a:r>
@@ -3193,8 +3189,8 @@
         </p:nvSpPr>
         <p:spPr>
           <a:xfrm rot="0">
-            <a:off x="15264803" y="9812655"/>
-            <a:ext cx="2637975" cy="474345"/>
+            <a:off x="14603066" y="9822180"/>
+            <a:ext cx="3299712" cy="464820"/>
           </a:xfrm>
           <a:prstGeom prst="rect">
             <a:avLst/>
@@ -3219,10 +3215,10 @@
                 <a:solidFill>
                   <a:srgbClr val="FFFFFF"/>
                 </a:solidFill>
-                <a:latin typeface="TDTD갬성명조"/>
-                <a:ea typeface="TDTD갬성명조"/>
-                <a:cs typeface="TDTD갬성명조"/>
-                <a:sym typeface="TDTD갬성명조"/>
+                <a:latin typeface="무궁화 고딕"/>
+                <a:ea typeface="무궁화 고딕"/>
+                <a:cs typeface="무궁화 고딕"/>
+                <a:sym typeface="무궁화 고딕"/>
               </a:rPr>
               <a:t>ⓒ 2026. Sunday Play</a:t>
             </a:r>
@@ -3269,8 +3265,8 @@
         </p:nvSpPr>
         <p:spPr>
           <a:xfrm rot="0">
-            <a:off x="2133812" y="3895725"/>
-            <a:ext cx="14020375" cy="2200275"/>
+            <a:off x="2133812" y="4252913"/>
+            <a:ext cx="14020375" cy="1771650"/>
           </a:xfrm>
           <a:prstGeom prst="rect">
             <a:avLst/>
@@ -3284,18 +3280,18 @@
           <a:p>
             <a:pPr algn="ctr">
               <a:lnSpc>
-                <a:spcPts val="15000"/>
+                <a:spcPts val="13920"/>
               </a:lnSpc>
             </a:pPr>
             <a:r>
-              <a:rPr lang="en-US" sz="12500">
+              <a:rPr lang="en-US" sz="11600">
                 <a:solidFill>
                   <a:srgbClr val="000000"/>
                 </a:solidFill>
-                <a:latin typeface="Jua"/>
-                <a:ea typeface="Jua"/>
-                <a:cs typeface="Jua"/>
-                <a:sym typeface="Jua"/>
+                <a:latin typeface="무궁화 고딕"/>
+                <a:ea typeface="무궁화 고딕"/>
+                <a:cs typeface="무궁화 고딕"/>
+                <a:sym typeface="무궁화 고딕"/>
               </a:rPr>
               <a:t>오른쪽 눈썹 그려주세요</a:t>
             </a:r>
@@ -3392,8 +3388,8 @@
         </p:nvSpPr>
         <p:spPr>
           <a:xfrm rot="0">
-            <a:off x="3238925" y="4092795"/>
-            <a:ext cx="11810151" cy="2200275"/>
+            <a:off x="3238925" y="4411883"/>
+            <a:ext cx="11810151" cy="1847850"/>
           </a:xfrm>
           <a:prstGeom prst="rect">
             <a:avLst/>
@@ -3407,18 +3403,18 @@
           <a:p>
             <a:pPr algn="ctr">
               <a:lnSpc>
-                <a:spcPts val="15000"/>
+                <a:spcPts val="14520"/>
               </a:lnSpc>
             </a:pPr>
             <a:r>
-              <a:rPr lang="en-US" sz="12500">
+              <a:rPr lang="en-US" sz="12100">
                 <a:solidFill>
                   <a:srgbClr val="000000"/>
                 </a:solidFill>
-                <a:latin typeface="Jua"/>
-                <a:ea typeface="Jua"/>
-                <a:cs typeface="Jua"/>
-                <a:sym typeface="Jua"/>
+                <a:latin typeface="무궁화 고딕"/>
+                <a:ea typeface="무궁화 고딕"/>
+                <a:cs typeface="무궁화 고딕"/>
+                <a:sym typeface="무궁화 고딕"/>
               </a:rPr>
               <a:t>왼쪽 귀 그려주세요</a:t>
             </a:r>
@@ -3515,8 +3511,8 @@
         </p:nvSpPr>
         <p:spPr>
           <a:xfrm rot="0">
-            <a:off x="1795135" y="3895725"/>
-            <a:ext cx="14697730" cy="2200275"/>
+            <a:off x="1795135" y="4181475"/>
+            <a:ext cx="14697730" cy="1914525"/>
           </a:xfrm>
           <a:prstGeom prst="rect">
             <a:avLst/>
@@ -3538,10 +3534,10 @@
                 <a:solidFill>
                   <a:srgbClr val="000000"/>
                 </a:solidFill>
-                <a:latin typeface="Jua"/>
-                <a:ea typeface="Jua"/>
-                <a:cs typeface="Jua"/>
-                <a:sym typeface="Jua"/>
+                <a:latin typeface="무궁화 고딕"/>
+                <a:ea typeface="무궁화 고딕"/>
+                <a:cs typeface="무궁화 고딕"/>
+                <a:sym typeface="무궁화 고딕"/>
               </a:rPr>
               <a:t>머리카락 그려주세요</a:t>
             </a:r>
@@ -3638,8 +3634,8 @@
         </p:nvSpPr>
         <p:spPr>
           <a:xfrm rot="0">
-            <a:off x="2998293" y="3895725"/>
-            <a:ext cx="12291414" cy="2200275"/>
+            <a:off x="2998293" y="4276725"/>
+            <a:ext cx="12291414" cy="1724025"/>
           </a:xfrm>
           <a:prstGeom prst="rect">
             <a:avLst/>
@@ -3653,18 +3649,18 @@
           <a:p>
             <a:pPr algn="ctr">
               <a:lnSpc>
-                <a:spcPts val="15000"/>
+                <a:spcPts val="13560"/>
               </a:lnSpc>
             </a:pPr>
             <a:r>
-              <a:rPr lang="en-US" sz="12500">
+              <a:rPr lang="en-US" sz="11300">
                 <a:solidFill>
                   <a:srgbClr val="000000"/>
                 </a:solidFill>
-                <a:latin typeface="Jua"/>
-                <a:ea typeface="Jua"/>
-                <a:cs typeface="Jua"/>
-                <a:sym typeface="Jua"/>
+                <a:latin typeface="무궁화 고딕"/>
+                <a:ea typeface="무궁화 고딕"/>
+                <a:cs typeface="무궁화 고딕"/>
+                <a:sym typeface="무궁화 고딕"/>
               </a:rPr>
               <a:t>오른쪽 눈 그려주세요</a:t>
             </a:r>
@@ -3761,8 +3757,8 @@
         </p:nvSpPr>
         <p:spPr>
           <a:xfrm rot="0">
-            <a:off x="2015714" y="3895725"/>
-            <a:ext cx="14256572" cy="2200275"/>
+            <a:off x="2015714" y="4181475"/>
+            <a:ext cx="14256572" cy="1914525"/>
           </a:xfrm>
           <a:prstGeom prst="rect">
             <a:avLst/>
@@ -3784,10 +3780,10 @@
                 <a:solidFill>
                   <a:srgbClr val="000000"/>
                 </a:solidFill>
-                <a:latin typeface="Jua"/>
-                <a:ea typeface="Jua"/>
-                <a:cs typeface="Jua"/>
-                <a:sym typeface="Jua"/>
+                <a:latin typeface="무궁화 고딕"/>
+                <a:ea typeface="무궁화 고딕"/>
+                <a:cs typeface="무궁화 고딕"/>
+                <a:sym typeface="무궁화 고딕"/>
               </a:rPr>
               <a:t>왼쪽 눈썹 그려주세요</a:t>
             </a:r>
@@ -3909,8 +3905,8 @@
         </p:nvSpPr>
         <p:spPr>
           <a:xfrm rot="0">
-            <a:off x="4421807" y="3895725"/>
-            <a:ext cx="9444385" cy="2200275"/>
+            <a:off x="4421807" y="4181475"/>
+            <a:ext cx="9444385" cy="1914525"/>
           </a:xfrm>
           <a:prstGeom prst="rect">
             <a:avLst/>
@@ -3932,10 +3928,10 @@
                 <a:solidFill>
                   <a:srgbClr val="000000"/>
                 </a:solidFill>
-                <a:latin typeface="Jua"/>
-                <a:ea typeface="Jua"/>
-                <a:cs typeface="Jua"/>
-                <a:sym typeface="Jua"/>
+                <a:latin typeface="무궁화 고딕"/>
+                <a:ea typeface="무궁화 고딕"/>
+                <a:cs typeface="무궁화 고딕"/>
+                <a:sym typeface="무궁화 고딕"/>
               </a:rPr>
               <a:t>감사합니다!</a:t>
             </a:r>
@@ -4134,8 +4130,8 @@
         </p:nvSpPr>
         <p:spPr>
           <a:xfrm rot="0">
-            <a:off x="11392761" y="600705"/>
-            <a:ext cx="5362043" cy="1600200"/>
+            <a:off x="11392761" y="819780"/>
+            <a:ext cx="5362043" cy="1381125"/>
           </a:xfrm>
           <a:prstGeom prst="rect">
             <a:avLst/>
@@ -4157,10 +4153,10 @@
                 <a:solidFill>
                   <a:srgbClr val="FFFAEF"/>
                 </a:solidFill>
-                <a:latin typeface="Jua"/>
-                <a:ea typeface="Jua"/>
-                <a:cs typeface="Jua"/>
-                <a:sym typeface="Jua"/>
+                <a:latin typeface="무궁화 고딕"/>
+                <a:ea typeface="무궁화 고딕"/>
+                <a:cs typeface="무궁화 고딕"/>
+                <a:sym typeface="무궁화 고딕"/>
               </a:rPr>
               <a:t>규칙</a:t>
             </a:r>
@@ -4176,9 +4172,9 @@
         <p:grpSpPr>
           <a:xfrm rot="0">
             <a:off x="309172" y="535073"/>
-            <a:ext cx="10694683" cy="2573620"/>
+            <a:ext cx="10694683" cy="2406534"/>
             <a:chOff x="0" y="0"/>
-            <a:chExt cx="14259577" cy="3431493"/>
+            <a:chExt cx="14259577" cy="3208711"/>
           </a:xfrm>
         </p:grpSpPr>
         <p:sp>
@@ -4189,8 +4185,8 @@
           </p:nvSpPr>
           <p:spPr>
             <a:xfrm rot="0">
-              <a:off x="0" y="1380584"/>
-              <a:ext cx="14259577" cy="2050910"/>
+              <a:off x="0" y="1388378"/>
+              <a:ext cx="14259577" cy="1820333"/>
             </a:xfrm>
             <a:prstGeom prst="rect">
               <a:avLst/>
@@ -4204,18 +4200,18 @@
             <a:p>
               <a:pPr algn="l">
                 <a:lnSpc>
-                  <a:spcPts val="6273"/>
+                  <a:spcPts val="5599"/>
                 </a:lnSpc>
               </a:pPr>
               <a:r>
-                <a:rPr lang="en-US" sz="4480">
+                <a:rPr lang="en-US" sz="3999">
                   <a:solidFill>
                     <a:srgbClr val="FFFAEF"/>
                   </a:solidFill>
-                  <a:latin typeface="TDTD가온"/>
-                  <a:ea typeface="TDTD가온"/>
-                  <a:cs typeface="TDTD가온"/>
-                  <a:sym typeface="TDTD가온"/>
+                  <a:latin typeface="무궁화 고딕"/>
+                  <a:ea typeface="무궁화 고딕"/>
+                  <a:cs typeface="무궁화 고딕"/>
+                  <a:sym typeface="무궁화 고딕"/>
                 </a:rPr>
                 <a:t>각 팀에서 맞추는 사람 1명, 모델 1명을 정합니다.                                 </a:t>
               </a:r>
@@ -4223,30 +4219,30 @@
             <a:p>
               <a:pPr algn="l">
                 <a:lnSpc>
-                  <a:spcPts val="6273"/>
+                  <a:spcPts val="5599"/>
                 </a:lnSpc>
               </a:pPr>
               <a:r>
-                <a:rPr lang="en-US" sz="4480">
+                <a:rPr lang="en-US" sz="3999">
                   <a:solidFill>
                     <a:srgbClr val="FFFAEF"/>
                   </a:solidFill>
-                  <a:latin typeface="TDTD가온"/>
-                  <a:ea typeface="TDTD가온"/>
-                  <a:cs typeface="TDTD가온"/>
-                  <a:sym typeface="TDTD가온"/>
+                  <a:latin typeface="무궁화 고딕"/>
+                  <a:ea typeface="무궁화 고딕"/>
+                  <a:cs typeface="무궁화 고딕"/>
+                  <a:sym typeface="무궁화 고딕"/>
                 </a:rPr>
                 <a:t>맞추는 사람은 뒤돌아 있고, 모델은</a:t>
               </a:r>
               <a:r>
-                <a:rPr lang="en-US" sz="4480">
+                <a:rPr lang="en-US" sz="3999">
                   <a:solidFill>
                     <a:srgbClr val="FFFAEF"/>
                   </a:solidFill>
-                  <a:latin typeface="TDTD가온"/>
-                  <a:ea typeface="TDTD가온"/>
-                  <a:cs typeface="TDTD가온"/>
-                  <a:sym typeface="TDTD가온"/>
+                  <a:latin typeface="무궁화 고딕"/>
+                  <a:ea typeface="무궁화 고딕"/>
+                  <a:cs typeface="무궁화 고딕"/>
+                  <a:sym typeface="무궁화 고딕"/>
                 </a:rPr>
                 <a:t> 앞에 섭니다. </a:t>
               </a:r>
@@ -4261,8 +4257,8 @@
           </p:nvSpPr>
           <p:spPr>
             <a:xfrm rot="0">
-              <a:off x="0" y="-171450"/>
-              <a:ext cx="9574913" cy="1169217"/>
+              <a:off x="0" y="-66675"/>
+              <a:ext cx="9574913" cy="1062712"/>
             </a:xfrm>
             <a:prstGeom prst="rect">
               <a:avLst/>
@@ -4284,10 +4280,10 @@
                   <a:solidFill>
                     <a:srgbClr val="FFFAEF"/>
                   </a:solidFill>
-                  <a:latin typeface="Jua"/>
-                  <a:ea typeface="Jua"/>
-                  <a:cs typeface="Jua"/>
-                  <a:sym typeface="Jua"/>
+                  <a:latin typeface="무궁화 고딕 Bold"/>
+                  <a:ea typeface="무궁화 고딕 Bold"/>
+                  <a:cs typeface="무궁화 고딕 Bold"/>
+                  <a:sym typeface="무궁화 고딕 Bold"/>
                 </a:rPr>
                 <a:t>STEP 1.</a:t>
               </a:r>
@@ -4303,10 +4299,10 @@
         </p:nvGrpSpPr>
         <p:grpSpPr>
           <a:xfrm rot="0">
-            <a:off x="12193423" y="7382817"/>
-            <a:ext cx="5459176" cy="2574122"/>
+            <a:off x="12289746" y="7483080"/>
+            <a:ext cx="5459176" cy="2402712"/>
             <a:chOff x="0" y="0"/>
-            <a:chExt cx="7278901" cy="3432162"/>
+            <a:chExt cx="7278901" cy="3203616"/>
           </a:xfrm>
         </p:grpSpPr>
         <p:sp>
@@ -4317,8 +4313,8 @@
           </p:nvSpPr>
           <p:spPr>
             <a:xfrm rot="0">
-              <a:off x="0" y="1377534"/>
-              <a:ext cx="7167620" cy="2054628"/>
+              <a:off x="0" y="1373758"/>
+              <a:ext cx="7167620" cy="1829858"/>
             </a:xfrm>
             <a:prstGeom prst="rect">
               <a:avLst/>
@@ -4332,30 +4328,30 @@
             <a:p>
               <a:pPr algn="l">
                 <a:lnSpc>
-                  <a:spcPts val="6284"/>
+                  <a:spcPts val="5600"/>
                 </a:lnSpc>
               </a:pPr>
               <a:r>
-                <a:rPr lang="en-US" sz="4489">
+                <a:rPr lang="en-US" sz="4000">
                   <a:solidFill>
                     <a:srgbClr val="FFFAEF"/>
                   </a:solidFill>
-                  <a:latin typeface="TDTD가온"/>
-                  <a:ea typeface="TDTD가온"/>
-                  <a:cs typeface="TDTD가온"/>
-                  <a:sym typeface="TDTD가온"/>
+                  <a:latin typeface="무궁화 고딕"/>
+                  <a:ea typeface="무궁화 고딕"/>
+                  <a:cs typeface="무궁화 고딕"/>
+                  <a:sym typeface="무궁화 고딕"/>
                 </a:rPr>
                 <a:t>맞추는 사람이 그림만 보고</a:t>
               </a:r>
               <a:r>
-                <a:rPr lang="en-US" sz="4489">
+                <a:rPr lang="en-US" sz="4000">
                   <a:solidFill>
                     <a:srgbClr val="FFFAEF"/>
                   </a:solidFill>
-                  <a:latin typeface="TDTD가온"/>
-                  <a:ea typeface="TDTD가온"/>
-                  <a:cs typeface="TDTD가온"/>
-                  <a:sym typeface="TDTD가온"/>
+                  <a:latin typeface="무궁화 고딕"/>
+                  <a:ea typeface="무궁화 고딕"/>
+                  <a:cs typeface="무궁화 고딕"/>
+                  <a:sym typeface="무궁화 고딕"/>
                 </a:rPr>
                 <a:t> 누구인지 맞히면 성공! </a:t>
               </a:r>
@@ -4370,8 +4366,8 @@
           </p:nvSpPr>
           <p:spPr>
             <a:xfrm rot="0">
-              <a:off x="0" y="-171450"/>
-              <a:ext cx="7278901" cy="1171105"/>
+              <a:off x="0" y="-57150"/>
+              <a:ext cx="7278901" cy="1053029"/>
             </a:xfrm>
             <a:prstGeom prst="rect">
               <a:avLst/>
@@ -4393,10 +4389,10 @@
                   <a:solidFill>
                     <a:srgbClr val="FFFAEF"/>
                   </a:solidFill>
-                  <a:latin typeface="Jua"/>
-                  <a:ea typeface="Jua"/>
-                  <a:cs typeface="Jua"/>
-                  <a:sym typeface="Jua"/>
+                  <a:latin typeface="무궁화 고딕 Bold"/>
+                  <a:ea typeface="무궁화 고딕 Bold"/>
+                  <a:cs typeface="무궁화 고딕 Bold"/>
+                  <a:sym typeface="무궁화 고딕 Bold"/>
                 </a:rPr>
                 <a:t>STEP 3.</a:t>
               </a:r>
@@ -4412,10 +4408,10 @@
         </p:nvGrpSpPr>
         <p:grpSpPr>
           <a:xfrm rot="0">
-            <a:off x="4621704" y="3960731"/>
-            <a:ext cx="10397630" cy="2570047"/>
+            <a:off x="4762073" y="4011213"/>
+            <a:ext cx="10397630" cy="2402261"/>
             <a:chOff x="0" y="0"/>
-            <a:chExt cx="13863507" cy="3426730"/>
+            <a:chExt cx="13863507" cy="3203015"/>
           </a:xfrm>
         </p:grpSpPr>
         <p:sp>
@@ -4426,8 +4422,8 @@
           </p:nvSpPr>
           <p:spPr>
             <a:xfrm rot="0">
-              <a:off x="0" y="1375218"/>
-              <a:ext cx="13863507" cy="2051512"/>
+              <a:off x="0" y="1382681"/>
+              <a:ext cx="13863507" cy="1820333"/>
             </a:xfrm>
             <a:prstGeom prst="rect">
               <a:avLst/>
@@ -4441,18 +4437,18 @@
             <a:p>
               <a:pPr algn="l">
                 <a:lnSpc>
-                  <a:spcPts val="6275"/>
+                  <a:spcPts val="5599"/>
                 </a:lnSpc>
               </a:pPr>
               <a:r>
-                <a:rPr lang="en-US" sz="4482">
+                <a:rPr lang="en-US" sz="3999">
                   <a:solidFill>
                     <a:srgbClr val="FFFAEF"/>
                   </a:solidFill>
-                  <a:latin typeface="TDTD가온"/>
-                  <a:ea typeface="TDTD가온"/>
-                  <a:cs typeface="TDTD가온"/>
-                  <a:sym typeface="TDTD가온"/>
+                  <a:latin typeface="무궁화 고딕"/>
+                  <a:ea typeface="무궁화 고딕"/>
+                  <a:cs typeface="무궁화 고딕"/>
+                  <a:sym typeface="무궁화 고딕"/>
                 </a:rPr>
                 <a:t>화면에 나오는 부위를 한 명씩                                           </a:t>
               </a:r>
@@ -4460,18 +4456,18 @@
             <a:p>
               <a:pPr algn="l">
                 <a:lnSpc>
-                  <a:spcPts val="6275"/>
+                  <a:spcPts val="5599"/>
                 </a:lnSpc>
               </a:pPr>
               <a:r>
-                <a:rPr lang="en-US" sz="4482">
+                <a:rPr lang="en-US" sz="3999">
                   <a:solidFill>
                     <a:srgbClr val="FFFAEF"/>
                   </a:solidFill>
-                  <a:latin typeface="TDTD가온"/>
-                  <a:ea typeface="TDTD가온"/>
-                  <a:cs typeface="TDTD가온"/>
-                  <a:sym typeface="TDTD가온"/>
+                  <a:latin typeface="무궁화 고딕"/>
+                  <a:ea typeface="무궁화 고딕"/>
+                  <a:cs typeface="무궁화 고딕"/>
+                  <a:sym typeface="무궁화 고딕"/>
                 </a:rPr>
                 <a:t>모델의 등 뒤로 가서 그리고 돌아옵니다.</a:t>
               </a:r>
@@ -4486,8 +4482,8 @@
           </p:nvSpPr>
           <p:spPr>
             <a:xfrm rot="0">
-              <a:off x="0" y="-171450"/>
-              <a:ext cx="6898637" cy="1169523"/>
+              <a:off x="0" y="-57150"/>
+              <a:ext cx="6898637" cy="1053161"/>
             </a:xfrm>
             <a:prstGeom prst="rect">
               <a:avLst/>
@@ -4509,10 +4505,10 @@
                   <a:solidFill>
                     <a:srgbClr val="FFFAEF"/>
                   </a:solidFill>
-                  <a:latin typeface="Jua"/>
-                  <a:ea typeface="Jua"/>
-                  <a:cs typeface="Jua"/>
-                  <a:sym typeface="Jua"/>
+                  <a:latin typeface="무궁화 고딕 Bold"/>
+                  <a:ea typeface="무궁화 고딕 Bold"/>
+                  <a:cs typeface="무궁화 고딕 Bold"/>
+                  <a:sym typeface="무궁화 고딕 Bold"/>
                 </a:rPr>
                 <a:t>STEP 2.</a:t>
               </a:r>
@@ -4560,8 +4556,8 @@
         </p:nvSpPr>
         <p:spPr>
           <a:xfrm rot="0">
-            <a:off x="3238925" y="4092795"/>
-            <a:ext cx="11810151" cy="2200275"/>
+            <a:off x="3238925" y="4378545"/>
+            <a:ext cx="11810151" cy="1914525"/>
           </a:xfrm>
           <a:prstGeom prst="rect">
             <a:avLst/>
@@ -4583,10 +4579,10 @@
                 <a:solidFill>
                   <a:srgbClr val="000000"/>
                 </a:solidFill>
-                <a:latin typeface="Jua"/>
-                <a:ea typeface="Jua"/>
-                <a:cs typeface="Jua"/>
-                <a:sym typeface="Jua"/>
+                <a:latin typeface="무궁화 고딕"/>
+                <a:ea typeface="무궁화 고딕"/>
+                <a:cs typeface="무궁화 고딕"/>
+                <a:sym typeface="무궁화 고딕"/>
               </a:rPr>
               <a:t>팀을 나눠주세요!</a:t>
             </a:r>
@@ -4733,8 +4729,8 @@
         </p:nvSpPr>
         <p:spPr>
           <a:xfrm rot="0">
-            <a:off x="1028700" y="3892867"/>
-            <a:ext cx="15555091" cy="2200275"/>
+            <a:off x="1028700" y="4178617"/>
+            <a:ext cx="15555091" cy="1914525"/>
           </a:xfrm>
           <a:prstGeom prst="rect">
             <a:avLst/>
@@ -4756,10 +4752,10 @@
                 <a:solidFill>
                   <a:srgbClr val="FFFAEF"/>
                 </a:solidFill>
-                <a:latin typeface="Jua"/>
-                <a:ea typeface="Jua"/>
-                <a:cs typeface="Jua"/>
-                <a:sym typeface="Jua"/>
+                <a:latin typeface="무궁화 고딕"/>
+                <a:ea typeface="무궁화 고딕"/>
+                <a:cs typeface="무궁화 고딕"/>
+                <a:sym typeface="무궁화 고딕"/>
               </a:rPr>
               <a:t>릴레이 초상화</a:t>
             </a:r>
@@ -4774,8 +4770,8 @@
         </p:nvSpPr>
         <p:spPr>
           <a:xfrm rot="0">
-            <a:off x="15264803" y="9812655"/>
-            <a:ext cx="2637975" cy="474345"/>
+            <a:off x="14603066" y="9822180"/>
+            <a:ext cx="3299712" cy="464820"/>
           </a:xfrm>
           <a:prstGeom prst="rect">
             <a:avLst/>
@@ -4800,10 +4796,10 @@
                 <a:solidFill>
                   <a:srgbClr val="FFFFFF"/>
                 </a:solidFill>
-                <a:latin typeface="TDTD갬성명조"/>
-                <a:ea typeface="TDTD갬성명조"/>
-                <a:cs typeface="TDTD갬성명조"/>
-                <a:sym typeface="TDTD갬성명조"/>
+                <a:latin typeface="무궁화 고딕"/>
+                <a:ea typeface="무궁화 고딕"/>
+                <a:cs typeface="무궁화 고딕"/>
+                <a:sym typeface="무궁화 고딕"/>
               </a:rPr>
               <a:t>ⓒ 2026. Sunday Play</a:t>
             </a:r>
@@ -4850,8 +4846,8 @@
         </p:nvSpPr>
         <p:spPr>
           <a:xfrm rot="0">
-            <a:off x="3238925" y="4092795"/>
-            <a:ext cx="11810151" cy="2200275"/>
+            <a:off x="3238925" y="4378545"/>
+            <a:ext cx="11810151" cy="1914525"/>
           </a:xfrm>
           <a:prstGeom prst="rect">
             <a:avLst/>
@@ -4873,10 +4869,10 @@
                 <a:solidFill>
                   <a:srgbClr val="000000"/>
                 </a:solidFill>
-                <a:latin typeface="Jua"/>
-                <a:ea typeface="Jua"/>
-                <a:cs typeface="Jua"/>
-                <a:sym typeface="Jua"/>
+                <a:latin typeface="무궁화 고딕"/>
+                <a:ea typeface="무궁화 고딕"/>
+                <a:cs typeface="무궁화 고딕"/>
+                <a:sym typeface="무궁화 고딕"/>
               </a:rPr>
               <a:t>얼굴형 그려주세요</a:t>
             </a:r>
@@ -4973,8 +4969,8 @@
         </p:nvSpPr>
         <p:spPr>
           <a:xfrm rot="0">
-            <a:off x="3238925" y="4092795"/>
-            <a:ext cx="11810151" cy="2200275"/>
+            <a:off x="3238925" y="4402358"/>
+            <a:ext cx="11810151" cy="1866900"/>
           </a:xfrm>
           <a:prstGeom prst="rect">
             <a:avLst/>
@@ -4988,18 +4984,18 @@
           <a:p>
             <a:pPr algn="ctr">
               <a:lnSpc>
-                <a:spcPts val="15000"/>
+                <a:spcPts val="14640"/>
               </a:lnSpc>
             </a:pPr>
             <a:r>
-              <a:rPr lang="en-US" sz="12500">
+              <a:rPr lang="en-US" sz="12200">
                 <a:solidFill>
                   <a:srgbClr val="000000"/>
                 </a:solidFill>
-                <a:latin typeface="Jua"/>
-                <a:ea typeface="Jua"/>
-                <a:cs typeface="Jua"/>
-                <a:sym typeface="Jua"/>
+                <a:latin typeface="무궁화 고딕"/>
+                <a:ea typeface="무궁화 고딕"/>
+                <a:cs typeface="무궁화 고딕"/>
+                <a:sym typeface="무궁화 고딕"/>
               </a:rPr>
               <a:t>왼쪽 눈 그려주세요</a:t>
             </a:r>
@@ -5096,8 +5092,8 @@
         </p:nvSpPr>
         <p:spPr>
           <a:xfrm rot="0">
-            <a:off x="3238925" y="4092795"/>
-            <a:ext cx="11810151" cy="2200275"/>
+            <a:off x="3238925" y="4378545"/>
+            <a:ext cx="11810151" cy="1914525"/>
           </a:xfrm>
           <a:prstGeom prst="rect">
             <a:avLst/>
@@ -5119,10 +5115,10 @@
                 <a:solidFill>
                   <a:srgbClr val="000000"/>
                 </a:solidFill>
-                <a:latin typeface="Jua"/>
-                <a:ea typeface="Jua"/>
-                <a:cs typeface="Jua"/>
-                <a:sym typeface="Jua"/>
+                <a:latin typeface="무궁화 고딕"/>
+                <a:ea typeface="무궁화 고딕"/>
+                <a:cs typeface="무궁화 고딕"/>
+                <a:sym typeface="무궁화 고딕"/>
               </a:rPr>
               <a:t>코 그려주세요</a:t>
             </a:r>
@@ -5219,8 +5215,8 @@
         </p:nvSpPr>
         <p:spPr>
           <a:xfrm rot="0">
-            <a:off x="2908056" y="3895725"/>
-            <a:ext cx="12471888" cy="2200275"/>
+            <a:off x="2908056" y="4257675"/>
+            <a:ext cx="12471888" cy="1762125"/>
           </a:xfrm>
           <a:prstGeom prst="rect">
             <a:avLst/>
@@ -5234,18 +5230,18 @@
           <a:p>
             <a:pPr algn="ctr">
               <a:lnSpc>
-                <a:spcPts val="15000"/>
+                <a:spcPts val="13800"/>
               </a:lnSpc>
             </a:pPr>
             <a:r>
-              <a:rPr lang="en-US" sz="12500">
+              <a:rPr lang="en-US" sz="11500">
                 <a:solidFill>
                   <a:srgbClr val="000000"/>
                 </a:solidFill>
-                <a:latin typeface="Jua"/>
-                <a:ea typeface="Jua"/>
-                <a:cs typeface="Jua"/>
-                <a:sym typeface="Jua"/>
+                <a:latin typeface="무궁화 고딕"/>
+                <a:ea typeface="무궁화 고딕"/>
+                <a:cs typeface="무궁화 고딕"/>
+                <a:sym typeface="무궁화 고딕"/>
               </a:rPr>
               <a:t>오른쪽 귀 그려주세요</a:t>
             </a:r>
@@ -5342,8 +5338,8 @@
         </p:nvSpPr>
         <p:spPr>
           <a:xfrm rot="0">
-            <a:off x="3238925" y="4092795"/>
-            <a:ext cx="11810151" cy="2200275"/>
+            <a:off x="3238925" y="4378545"/>
+            <a:ext cx="11810151" cy="1914525"/>
           </a:xfrm>
           <a:prstGeom prst="rect">
             <a:avLst/>
@@ -5365,10 +5361,10 @@
                 <a:solidFill>
                   <a:srgbClr val="000000"/>
                 </a:solidFill>
-                <a:latin typeface="Jua"/>
-                <a:ea typeface="Jua"/>
-                <a:cs typeface="Jua"/>
-                <a:sym typeface="Jua"/>
+                <a:latin typeface="무궁화 고딕"/>
+                <a:ea typeface="무궁화 고딕"/>
+                <a:cs typeface="무궁화 고딕"/>
+                <a:sym typeface="무궁화 고딕"/>
               </a:rPr>
               <a:t>입 그려주세요</a:t>
             </a:r>

</xml_diff>